<commit_message>
Router vs Switch which one comes after which as per connectivity, functionality and network layers
</commit_message>
<xml_diff>
--- a/network/sir-slides/4. Networking for Web Developers.pptx
+++ b/network/sir-slides/4. Networking for Web Developers.pptx
@@ -21259,7 +21259,73 @@
                 <a:ea typeface="QuattrocentoSans" pitchFamily="34" charset="-122"/>
                 <a:cs typeface="QuattrocentoSans" pitchFamily="34" charset="-120"/>
               </a:rPr>
-              <a:t>Intra-network communication</a:t>
+              <a:t>Intra-network communication (</a:t>
+            </a:r>
+            <a:r>
+              <a:rPr lang="en-US" sz="1800" dirty="0" err="1">
+                <a:solidFill>
+                  <a:srgbClr val="2D3142"/>
+                </a:solidFill>
+                <a:latin typeface="QuattrocentoSans" pitchFamily="34" charset="0"/>
+                <a:ea typeface="QuattrocentoSans" pitchFamily="34" charset="-122"/>
+                <a:cs typeface="QuattrocentoSans" pitchFamily="34" charset="-120"/>
+              </a:rPr>
+              <a:t>Eg.</a:t>
+            </a:r>
+            <a:r>
+              <a:rPr lang="en-US" sz="1800" dirty="0">
+                <a:solidFill>
+                  <a:srgbClr val="2D3142"/>
+                </a:solidFill>
+                <a:latin typeface="QuattrocentoSans" pitchFamily="34" charset="0"/>
+                <a:ea typeface="QuattrocentoSans" pitchFamily="34" charset="-122"/>
+                <a:cs typeface="QuattrocentoSans" pitchFamily="34" charset="-120"/>
+              </a:rPr>
+              <a:t> Data pass via </a:t>
+            </a:r>
+            <a:r>
+              <a:rPr lang="en-US" dirty="0">
+                <a:solidFill>
+                  <a:srgbClr val="2D3142"/>
+                </a:solidFill>
+                <a:latin typeface="QuattrocentoSans" pitchFamily="34" charset="0"/>
+                <a:ea typeface="QuattrocentoSans" pitchFamily="34" charset="-122"/>
+                <a:cs typeface="QuattrocentoSans" pitchFamily="34" charset="-120"/>
+              </a:rPr>
+              <a:t>Local share </a:t>
+            </a:r>
+            <a:r>
+              <a:rPr lang="en-US" sz="1800" dirty="0">
+                <a:solidFill>
+                  <a:srgbClr val="2D3142"/>
+                </a:solidFill>
+                <a:latin typeface="QuattrocentoSans" pitchFamily="34" charset="0"/>
+                <a:ea typeface="QuattrocentoSans" pitchFamily="34" charset="-122"/>
+                <a:cs typeface="QuattrocentoSans" pitchFamily="34" charset="-120"/>
+              </a:rPr>
+              <a:t>Software like, </a:t>
+            </a:r>
+            <a:r>
+              <a:rPr lang="en-US" sz="1800" dirty="0" err="1">
+                <a:solidFill>
+                  <a:srgbClr val="2D3142"/>
+                </a:solidFill>
+                <a:latin typeface="QuattrocentoSans" pitchFamily="34" charset="0"/>
+                <a:ea typeface="QuattrocentoSans" pitchFamily="34" charset="-122"/>
+                <a:cs typeface="QuattrocentoSans" pitchFamily="34" charset="-120"/>
+              </a:rPr>
+              <a:t>shareIt</a:t>
+            </a:r>
+            <a:r>
+              <a:rPr lang="en-US" sz="1800">
+                <a:solidFill>
+                  <a:srgbClr val="2D3142"/>
+                </a:solidFill>
+                <a:latin typeface="QuattrocentoSans" pitchFamily="34" charset="0"/>
+                <a:ea typeface="QuattrocentoSans" pitchFamily="34" charset="-122"/>
+                <a:cs typeface="QuattrocentoSans" pitchFamily="34" charset="-120"/>
+              </a:rPr>
+              <a:t>) </a:t>
             </a:r>
             <a:endParaRPr lang="en-US" sz="1800" dirty="0"/>
           </a:p>

</xml_diff>

<commit_message>
RFC 1918, NAT short, DHCP, Subnet, guest home subnet
</commit_message>
<xml_diff>
--- a/network/sir-slides/4. Networking for Web Developers.pptx
+++ b/network/sir-slides/4. Networking for Web Developers.pptx
@@ -2670,7 +2670,7 @@
         </p:nvGraphicFramePr>
         <p:xfrm>
           <a:off x="762000" y="1524000"/>
-          <a:ext cx="14732000" cy="5080000"/>
+          <a:ext cx="14732000" cy="5080001"/>
         </p:xfrm>
         <a:graphic>
           <a:graphicData uri="http://schemas.openxmlformats.org/drawingml/2006/table">
@@ -21259,10 +21259,10 @@
                 <a:ea typeface="QuattrocentoSans" pitchFamily="34" charset="-122"/>
                 <a:cs typeface="QuattrocentoSans" pitchFamily="34" charset="-120"/>
               </a:rPr>
-              <a:t>Intra-network communication (</a:t>
-            </a:r>
-            <a:r>
-              <a:rPr lang="en-US" sz="1800" dirty="0" err="1">
+              <a:t>Intra-network communication </a:t>
+            </a:r>
+            <a:r>
+              <a:rPr lang="en-US" sz="1200" dirty="0">
                 <a:solidFill>
                   <a:srgbClr val="2D3142"/>
                 </a:solidFill>
@@ -21270,10 +21270,10 @@
                 <a:ea typeface="QuattrocentoSans" pitchFamily="34" charset="-122"/>
                 <a:cs typeface="QuattrocentoSans" pitchFamily="34" charset="-120"/>
               </a:rPr>
-              <a:t>Eg.</a:t>
-            </a:r>
-            <a:r>
-              <a:rPr lang="en-US" sz="1800" dirty="0">
+              <a:t>(</a:t>
+            </a:r>
+            <a:r>
+              <a:rPr lang="en-US" sz="1200" dirty="0" err="1">
                 <a:solidFill>
                   <a:srgbClr val="2D3142"/>
                 </a:solidFill>
@@ -21281,10 +21281,10 @@
                 <a:ea typeface="QuattrocentoSans" pitchFamily="34" charset="-122"/>
                 <a:cs typeface="QuattrocentoSans" pitchFamily="34" charset="-120"/>
               </a:rPr>
-              <a:t> Data pass via </a:t>
-            </a:r>
-            <a:r>
-              <a:rPr lang="en-US" dirty="0">
+              <a:t>Eg.</a:t>
+            </a:r>
+            <a:r>
+              <a:rPr lang="en-US" sz="1200" dirty="0">
                 <a:solidFill>
                   <a:srgbClr val="2D3142"/>
                 </a:solidFill>
@@ -21292,10 +21292,10 @@
                 <a:ea typeface="QuattrocentoSans" pitchFamily="34" charset="-122"/>
                 <a:cs typeface="QuattrocentoSans" pitchFamily="34" charset="-120"/>
               </a:rPr>
-              <a:t>Local share </a:t>
-            </a:r>
-            <a:r>
-              <a:rPr lang="en-US" sz="1800" dirty="0">
+              <a:t> Data pass via Local share Software like, </a:t>
+            </a:r>
+            <a:r>
+              <a:rPr lang="en-US" sz="1200" dirty="0" err="1">
                 <a:solidFill>
                   <a:srgbClr val="2D3142"/>
                 </a:solidFill>
@@ -21303,21 +21303,10 @@
                 <a:ea typeface="QuattrocentoSans" pitchFamily="34" charset="-122"/>
                 <a:cs typeface="QuattrocentoSans" pitchFamily="34" charset="-120"/>
               </a:rPr>
-              <a:t>Software like, </a:t>
-            </a:r>
-            <a:r>
-              <a:rPr lang="en-US" sz="1800" dirty="0" err="1">
-                <a:solidFill>
-                  <a:srgbClr val="2D3142"/>
-                </a:solidFill>
-                <a:latin typeface="QuattrocentoSans" pitchFamily="34" charset="0"/>
-                <a:ea typeface="QuattrocentoSans" pitchFamily="34" charset="-122"/>
-                <a:cs typeface="QuattrocentoSans" pitchFamily="34" charset="-120"/>
-              </a:rPr>
               <a:t>shareIt</a:t>
             </a:r>
             <a:r>
-              <a:rPr lang="en-US" sz="1800">
+              <a:rPr lang="en-US" sz="1200" dirty="0">
                 <a:solidFill>
                   <a:srgbClr val="2D3142"/>
                 </a:solidFill>
@@ -21798,7 +21787,7 @@
               </a:lnSpc>
             </a:pPr>
             <a:r>
-              <a:rPr lang="en-US" sz="1400" dirty="0">
+              <a:rPr lang="en-US" sz="1400" b="1" dirty="0">
                 <a:solidFill>
                   <a:srgbClr val="8D99AE"/>
                 </a:solidFill>
@@ -21808,7 +21797,7 @@
               </a:rPr>
               <a:t>32-bit address</a:t>
             </a:r>
-            <a:endParaRPr lang="en-US" sz="1600" dirty="0"/>
+            <a:endParaRPr lang="en-US" sz="1600" b="1" dirty="0"/>
           </a:p>
         </p:txBody>
       </p:sp>
@@ -21888,7 +21877,7 @@
                 <a:ea typeface="QuattrocentoSans" pitchFamily="34" charset="-122"/>
                 <a:cs typeface="QuattrocentoSans" pitchFamily="34" charset="-120"/>
               </a:rPr>
-              <a:t>• Four octets (0-255) separated by dots</a:t>
+              <a:t>• Four octets (0-255) separated by dots </a:t>
             </a:r>
             <a:endParaRPr lang="en-US" sz="1800" dirty="0"/>
           </a:p>
@@ -22027,7 +22016,7 @@
               </a:lnSpc>
             </a:pPr>
             <a:r>
-              <a:rPr lang="en-US" sz="1400" dirty="0">
+              <a:rPr lang="en-US" sz="1400" b="1" dirty="0">
                 <a:solidFill>
                   <a:srgbClr val="8D99AE"/>
                 </a:solidFill>
@@ -22037,7 +22026,7 @@
               </a:rPr>
               <a:t>128-bit address</a:t>
             </a:r>
-            <a:endParaRPr lang="en-US" sz="1600" dirty="0"/>
+            <a:endParaRPr lang="en-US" sz="1600" b="1" dirty="0"/>
           </a:p>
         </p:txBody>
       </p:sp>
@@ -23683,13 +23672,45 @@
                 <a:solidFill>
                   <a:srgbClr val="2D3142"/>
                 </a:solidFill>
+                <a:highlight>
+                  <a:srgbClr val="FFFF00"/>
+                </a:highlight>
                 <a:latin typeface="QuattrocentoSans" pitchFamily="34" charset="0"/>
                 <a:ea typeface="QuattrocentoSans" pitchFamily="34" charset="-122"/>
                 <a:cs typeface="QuattrocentoSans" pitchFamily="34" charset="-120"/>
               </a:rPr>
-              <a:t>Globally unique address reachable from anywhere on the Internet</a:t>
-            </a:r>
-            <a:endParaRPr lang="en-US" sz="1800" dirty="0"/>
+              <a:t>Globally unique</a:t>
+            </a:r>
+            <a:r>
+              <a:rPr lang="en-US" sz="1600" dirty="0">
+                <a:solidFill>
+                  <a:srgbClr val="2D3142"/>
+                </a:solidFill>
+                <a:latin typeface="QuattrocentoSans" pitchFamily="34" charset="0"/>
+                <a:ea typeface="QuattrocentoSans" pitchFamily="34" charset="-122"/>
+                <a:cs typeface="QuattrocentoSans" pitchFamily="34" charset="-120"/>
+              </a:rPr>
+              <a:t> address </a:t>
+            </a:r>
+            <a:r>
+              <a:rPr lang="en-US" sz="1600" dirty="0">
+                <a:solidFill>
+                  <a:srgbClr val="2D3142"/>
+                </a:solidFill>
+                <a:highlight>
+                  <a:srgbClr val="FFFF00"/>
+                </a:highlight>
+                <a:latin typeface="QuattrocentoSans" pitchFamily="34" charset="0"/>
+                <a:ea typeface="QuattrocentoSans" pitchFamily="34" charset="-122"/>
+                <a:cs typeface="QuattrocentoSans" pitchFamily="34" charset="-120"/>
+              </a:rPr>
+              <a:t>reachable from anywhere on the Internet</a:t>
+            </a:r>
+            <a:endParaRPr lang="en-US" sz="1800" dirty="0">
+              <a:highlight>
+                <a:srgbClr val="FFFF00"/>
+              </a:highlight>
+            </a:endParaRPr>
           </a:p>
           <a:p>
             <a:pPr>
@@ -23890,7 +23911,25 @@
                 <a:ea typeface="QuattrocentoSans" pitchFamily="34" charset="-122"/>
                 <a:cs typeface="QuattrocentoSans" pitchFamily="34" charset="-120"/>
               </a:rPr>
-              <a:t>The router assigns private IPs via DHCP and manages the single public IP from ISP</a:t>
+              <a:t>The router assigns private IPs via DHCP (Dynamic Host Configuration Protocol)</a:t>
+            </a:r>
+          </a:p>
+          <a:p>
+            <a:pPr>
+              <a:lnSpc>
+                <a:spcPct val="160000"/>
+              </a:lnSpc>
+            </a:pPr>
+            <a:r>
+              <a:rPr lang="en-US" sz="1600" dirty="0">
+                <a:solidFill>
+                  <a:srgbClr val="2D3142"/>
+                </a:solidFill>
+                <a:latin typeface="QuattrocentoSans" pitchFamily="34" charset="0"/>
+                <a:ea typeface="QuattrocentoSans" pitchFamily="34" charset="-122"/>
+                <a:cs typeface="QuattrocentoSans" pitchFamily="34" charset="-120"/>
+              </a:rPr>
+              <a:t> and manages the single public IP from ISP</a:t>
             </a:r>
             <a:endParaRPr lang="en-US" sz="1800" dirty="0"/>
           </a:p>

</xml_diff>

<commit_message>
NAT, ARP, Deafult Gateway, Broadcast address, ARP vs DHCP
</commit_message>
<xml_diff>
--- a/network/sir-slides/4. Networking for Web Developers.pptx
+++ b/network/sir-slides/4. Networking for Web Developers.pptx
@@ -23698,7 +23698,7 @@
                   <a:srgbClr val="2D3142"/>
                 </a:solidFill>
                 <a:highlight>
-                  <a:srgbClr val="FFFF00"/>
+                  <a:srgbClr val="00FF00"/>
                 </a:highlight>
                 <a:latin typeface="QuattrocentoSans" pitchFamily="34" charset="0"/>
                 <a:ea typeface="QuattrocentoSans" pitchFamily="34" charset="-122"/>
@@ -23708,7 +23708,7 @@
             </a:r>
             <a:endParaRPr lang="en-US" sz="1800" dirty="0">
               <a:highlight>
-                <a:srgbClr val="FFFF00"/>
+                <a:srgbClr val="00FF00"/>
               </a:highlight>
             </a:endParaRPr>
           </a:p>
@@ -23730,28 +23730,27 @@
                 <a:ea typeface="QuattrocentoSans" pitchFamily="34" charset="-122"/>
                 <a:cs typeface="QuattrocentoSans" pitchFamily="34" charset="-120"/>
               </a:rPr>
-              <a:t>• Assigned by your ISP</a:t>
-            </a:r>
-            <a:endParaRPr lang="en-US" sz="1800" dirty="0"/>
-          </a:p>
-          <a:p>
-            <a:pPr>
-              <a:lnSpc>
-                <a:spcPct val="160000"/>
-              </a:lnSpc>
-            </a:pPr>
+              <a:t>• Assigned by your </a:t>
+            </a:r>
             <a:r>
               <a:rPr lang="en-US" sz="1600" dirty="0">
                 <a:solidFill>
                   <a:srgbClr val="2D3142"/>
                 </a:solidFill>
+                <a:highlight>
+                  <a:srgbClr val="00FF00"/>
+                </a:highlight>
                 <a:latin typeface="QuattrocentoSans" pitchFamily="34" charset="0"/>
                 <a:ea typeface="QuattrocentoSans" pitchFamily="34" charset="-122"/>
                 <a:cs typeface="QuattrocentoSans" pitchFamily="34" charset="-120"/>
               </a:rPr>
-              <a:t>• One per network (typically)</a:t>
-            </a:r>
-            <a:endParaRPr lang="en-US" sz="1800" dirty="0"/>
+              <a:t>ISP</a:t>
+            </a:r>
+            <a:endParaRPr lang="en-US" sz="1800" dirty="0">
+              <a:highlight>
+                <a:srgbClr val="00FF00"/>
+              </a:highlight>
+            </a:endParaRPr>
           </a:p>
           <a:p>
             <a:pPr>
@@ -23768,9 +23767,71 @@
                 <a:ea typeface="QuattrocentoSans" pitchFamily="34" charset="-122"/>
                 <a:cs typeface="QuattrocentoSans" pitchFamily="34" charset="-120"/>
               </a:rPr>
-              <a:t>• Required for Internet access</a:t>
+              <a:t>• </a:t>
+            </a:r>
+            <a:r>
+              <a:rPr lang="en-US" sz="1600" dirty="0">
+                <a:solidFill>
+                  <a:srgbClr val="2D3142"/>
+                </a:solidFill>
+                <a:highlight>
+                  <a:srgbClr val="00FF00"/>
+                </a:highlight>
+                <a:latin typeface="QuattrocentoSans" pitchFamily="34" charset="0"/>
+                <a:ea typeface="QuattrocentoSans" pitchFamily="34" charset="-122"/>
+                <a:cs typeface="QuattrocentoSans" pitchFamily="34" charset="-120"/>
+              </a:rPr>
+              <a:t>One per network </a:t>
+            </a:r>
+            <a:r>
+              <a:rPr lang="en-US" sz="1600" dirty="0">
+                <a:solidFill>
+                  <a:srgbClr val="2D3142"/>
+                </a:solidFill>
+                <a:latin typeface="QuattrocentoSans" pitchFamily="34" charset="0"/>
+                <a:ea typeface="QuattrocentoSans" pitchFamily="34" charset="-122"/>
+                <a:cs typeface="QuattrocentoSans" pitchFamily="34" charset="-120"/>
+              </a:rPr>
+              <a:t>(typically)</a:t>
             </a:r>
             <a:endParaRPr lang="en-US" sz="1800" dirty="0"/>
+          </a:p>
+          <a:p>
+            <a:pPr>
+              <a:lnSpc>
+                <a:spcPct val="160000"/>
+              </a:lnSpc>
+            </a:pPr>
+            <a:r>
+              <a:rPr lang="en-US" sz="1600" dirty="0">
+                <a:solidFill>
+                  <a:srgbClr val="2D3142"/>
+                </a:solidFill>
+                <a:latin typeface="QuattrocentoSans" pitchFamily="34" charset="0"/>
+                <a:ea typeface="QuattrocentoSans" pitchFamily="34" charset="-122"/>
+                <a:cs typeface="QuattrocentoSans" pitchFamily="34" charset="-120"/>
+              </a:rPr>
+              <a:t>• </a:t>
+            </a:r>
+            <a:r>
+              <a:rPr lang="en-US" sz="1600" dirty="0">
+                <a:solidFill>
+                  <a:srgbClr val="2D3142"/>
+                </a:solidFill>
+                <a:highlight>
+                  <a:srgbClr val="00FF00"/>
+                </a:highlight>
+                <a:latin typeface="QuattrocentoSans" pitchFamily="34" charset="0"/>
+                <a:ea typeface="QuattrocentoSans" pitchFamily="34" charset="-122"/>
+                <a:cs typeface="QuattrocentoSans" pitchFamily="34" charset="-120"/>
+              </a:rPr>
+              <a:t>Required for Internet access</a:t>
+            </a:r>
+            <a:endParaRPr lang="en-US" sz="1800" dirty="0">
+              <a:highlight>
+                <a:srgbClr val="00FF00"/>
+              </a:highlight>
+            </a:endParaRPr>
           </a:p>
         </p:txBody>
       </p:sp>
@@ -23911,27 +23972,70 @@
                 <a:ea typeface="QuattrocentoSans" pitchFamily="34" charset="-122"/>
                 <a:cs typeface="QuattrocentoSans" pitchFamily="34" charset="-120"/>
               </a:rPr>
-              <a:t>The router assigns private IPs via DHCP (Dynamic Host Configuration Protocol)</a:t>
-            </a:r>
-          </a:p>
-          <a:p>
-            <a:pPr>
-              <a:lnSpc>
-                <a:spcPct val="160000"/>
-              </a:lnSpc>
-            </a:pPr>
+              <a:t>The </a:t>
+            </a:r>
             <a:r>
               <a:rPr lang="en-US" sz="1600" dirty="0">
                 <a:solidFill>
                   <a:srgbClr val="2D3142"/>
                 </a:solidFill>
+                <a:highlight>
+                  <a:srgbClr val="FFFF00"/>
+                </a:highlight>
                 <a:latin typeface="QuattrocentoSans" pitchFamily="34" charset="0"/>
                 <a:ea typeface="QuattrocentoSans" pitchFamily="34" charset="-122"/>
                 <a:cs typeface="QuattrocentoSans" pitchFamily="34" charset="-120"/>
               </a:rPr>
-              <a:t> and manages the single public IP from ISP</a:t>
-            </a:r>
-            <a:endParaRPr lang="en-US" sz="1800" dirty="0"/>
+              <a:t>router assigns private IPs via DHCP </a:t>
+            </a:r>
+            <a:r>
+              <a:rPr lang="en-US" sz="1600" dirty="0">
+                <a:solidFill>
+                  <a:srgbClr val="2D3142"/>
+                </a:solidFill>
+                <a:latin typeface="QuattrocentoSans" pitchFamily="34" charset="0"/>
+                <a:ea typeface="QuattrocentoSans" pitchFamily="34" charset="-122"/>
+                <a:cs typeface="QuattrocentoSans" pitchFamily="34" charset="-120"/>
+              </a:rPr>
+              <a:t>(Dynamic Host Configuration Protocol)</a:t>
+            </a:r>
+          </a:p>
+          <a:p>
+            <a:pPr>
+              <a:lnSpc>
+                <a:spcPct val="160000"/>
+              </a:lnSpc>
+            </a:pPr>
+            <a:r>
+              <a:rPr lang="en-US" sz="1600" dirty="0">
+                <a:solidFill>
+                  <a:srgbClr val="2D3142"/>
+                </a:solidFill>
+                <a:latin typeface="QuattrocentoSans" pitchFamily="34" charset="0"/>
+                <a:ea typeface="QuattrocentoSans" pitchFamily="34" charset="-122"/>
+                <a:cs typeface="QuattrocentoSans" pitchFamily="34" charset="-120"/>
+              </a:rPr>
+              <a:t> and </a:t>
+            </a:r>
+            <a:r>
+              <a:rPr lang="en-US" sz="1600" dirty="0">
+                <a:solidFill>
+                  <a:srgbClr val="2D3142"/>
+                </a:solidFill>
+                <a:highlight>
+                  <a:srgbClr val="00FF00"/>
+                </a:highlight>
+                <a:latin typeface="QuattrocentoSans" pitchFamily="34" charset="0"/>
+                <a:ea typeface="QuattrocentoSans" pitchFamily="34" charset="-122"/>
+                <a:cs typeface="QuattrocentoSans" pitchFamily="34" charset="-120"/>
+              </a:rPr>
+              <a:t>manages the single public IP from ISP</a:t>
+            </a:r>
+            <a:endParaRPr lang="en-US" sz="1800" dirty="0">
+              <a:highlight>
+                <a:srgbClr val="00FF00"/>
+              </a:highlight>
+            </a:endParaRPr>
           </a:p>
           <a:p>
             <a:pPr>
@@ -23951,16 +24055,12 @@
                 <a:ea typeface="QuattrocentoSans" pitchFamily="34" charset="-122"/>
                 <a:cs typeface="QuattrocentoSans" pitchFamily="34" charset="-120"/>
               </a:rPr>
-              <a:t>• NAT translates between them</a:t>
-            </a:r>
-            <a:endParaRPr lang="en-US" sz="1800" dirty="0"/>
-          </a:p>
-          <a:p>
-            <a:pPr>
-              <a:lnSpc>
-                <a:spcPct val="160000"/>
-              </a:lnSpc>
-            </a:pPr>
+              <a:t>• NAT (</a:t>
+            </a:r>
+            <a:r>
+              <a:rPr lang="en-US" sz="1600" dirty="0"/>
+              <a:t>Network Address Translation)</a:t>
+            </a:r>
             <a:r>
               <a:rPr lang="en-US" sz="1600" dirty="0">
                 <a:solidFill>
@@ -23970,7 +24070,7 @@
                 <a:ea typeface="QuattrocentoSans" pitchFamily="34" charset="-122"/>
                 <a:cs typeface="QuattrocentoSans" pitchFamily="34" charset="-120"/>
               </a:rPr>
-              <a:t>• ~18M devices reuse same ranges</a:t>
+              <a:t> translates between them</a:t>
             </a:r>
             <a:endParaRPr lang="en-US" sz="1800" dirty="0"/>
           </a:p>
@@ -23989,7 +24089,94 @@
                 <a:ea typeface="QuattrocentoSans" pitchFamily="34" charset="-122"/>
                 <a:cs typeface="QuattrocentoSans" pitchFamily="34" charset="-120"/>
               </a:rPr>
-              <a:t>• Isolates local from global traffic</a:t>
+              <a:t>• ~18M devices </a:t>
+            </a:r>
+            <a:r>
+              <a:rPr lang="en-US" sz="1600" dirty="0">
+                <a:solidFill>
+                  <a:srgbClr val="2D3142"/>
+                </a:solidFill>
+                <a:highlight>
+                  <a:srgbClr val="00FF00"/>
+                </a:highlight>
+                <a:latin typeface="QuattrocentoSans" pitchFamily="34" charset="0"/>
+                <a:ea typeface="QuattrocentoSans" pitchFamily="34" charset="-122"/>
+                <a:cs typeface="QuattrocentoSans" pitchFamily="34" charset="-120"/>
+              </a:rPr>
+              <a:t>reuse</a:t>
+            </a:r>
+            <a:r>
+              <a:rPr lang="en-US" sz="1600" dirty="0">
+                <a:solidFill>
+                  <a:srgbClr val="2D3142"/>
+                </a:solidFill>
+                <a:latin typeface="QuattrocentoSans" pitchFamily="34" charset="0"/>
+                <a:ea typeface="QuattrocentoSans" pitchFamily="34" charset="-122"/>
+                <a:cs typeface="QuattrocentoSans" pitchFamily="34" charset="-120"/>
+              </a:rPr>
+              <a:t> </a:t>
+            </a:r>
+            <a:r>
+              <a:rPr lang="en-US" sz="1600" dirty="0">
+                <a:solidFill>
+                  <a:srgbClr val="2D3142"/>
+                </a:solidFill>
+                <a:highlight>
+                  <a:srgbClr val="00FF00"/>
+                </a:highlight>
+                <a:latin typeface="QuattrocentoSans" pitchFamily="34" charset="0"/>
+                <a:ea typeface="QuattrocentoSans" pitchFamily="34" charset="-122"/>
+                <a:cs typeface="QuattrocentoSans" pitchFamily="34" charset="-120"/>
+              </a:rPr>
+              <a:t>same ranges</a:t>
+            </a:r>
+            <a:endParaRPr lang="en-US" sz="1800" dirty="0">
+              <a:highlight>
+                <a:srgbClr val="00FF00"/>
+              </a:highlight>
+            </a:endParaRPr>
+          </a:p>
+          <a:p>
+            <a:pPr>
+              <a:lnSpc>
+                <a:spcPct val="160000"/>
+              </a:lnSpc>
+            </a:pPr>
+            <a:r>
+              <a:rPr lang="en-US" sz="1600" dirty="0">
+                <a:solidFill>
+                  <a:srgbClr val="2D3142"/>
+                </a:solidFill>
+                <a:latin typeface="QuattrocentoSans" pitchFamily="34" charset="0"/>
+                <a:ea typeface="QuattrocentoSans" pitchFamily="34" charset="-122"/>
+                <a:cs typeface="QuattrocentoSans" pitchFamily="34" charset="-120"/>
+              </a:rPr>
+              <a:t>• </a:t>
+            </a:r>
+            <a:r>
+              <a:rPr lang="en-US" sz="1600" dirty="0">
+                <a:solidFill>
+                  <a:srgbClr val="2D3142"/>
+                </a:solidFill>
+                <a:highlight>
+                  <a:srgbClr val="00FF00"/>
+                </a:highlight>
+                <a:latin typeface="QuattrocentoSans" pitchFamily="34" charset="0"/>
+                <a:ea typeface="QuattrocentoSans" pitchFamily="34" charset="-122"/>
+                <a:cs typeface="QuattrocentoSans" pitchFamily="34" charset="-120"/>
+              </a:rPr>
+              <a:t>Isolates local </a:t>
+            </a:r>
+            <a:r>
+              <a:rPr lang="en-US" sz="1600" dirty="0">
+                <a:solidFill>
+                  <a:srgbClr val="2D3142"/>
+                </a:solidFill>
+                <a:latin typeface="QuattrocentoSans" pitchFamily="34" charset="0"/>
+                <a:ea typeface="QuattrocentoSans" pitchFamily="34" charset="-122"/>
+                <a:cs typeface="QuattrocentoSans" pitchFamily="34" charset="-120"/>
+              </a:rPr>
+              <a:t>from global traffic</a:t>
             </a:r>
             <a:endParaRPr lang="en-US" sz="1800" dirty="0"/>
           </a:p>
@@ -24213,7 +24400,51 @@
                 <a:ea typeface="QuattrocentoSans" pitchFamily="34" charset="-122"/>
                 <a:cs typeface="QuattrocentoSans" pitchFamily="34" charset="-120"/>
               </a:rPr>
-              <a:t> address is a hardware-level identifier burned into every Network Interface Card (NIC). It serves as a permanent, unique identity for each network device.</a:t>
+              <a:t> address is a </a:t>
+            </a:r>
+            <a:r>
+              <a:rPr lang="en-US" sz="1800" b="1" dirty="0">
+                <a:solidFill>
+                  <a:srgbClr val="2D3142"/>
+                </a:solidFill>
+                <a:latin typeface="QuattrocentoSans" pitchFamily="34" charset="0"/>
+                <a:ea typeface="QuattrocentoSans" pitchFamily="34" charset="-122"/>
+                <a:cs typeface="QuattrocentoSans" pitchFamily="34" charset="-120"/>
+              </a:rPr>
+              <a:t>hardware-level identifier </a:t>
+            </a:r>
+            <a:r>
+              <a:rPr lang="en-US" sz="1800" dirty="0">
+                <a:solidFill>
+                  <a:srgbClr val="2D3142"/>
+                </a:solidFill>
+                <a:latin typeface="QuattrocentoSans" pitchFamily="34" charset="0"/>
+                <a:ea typeface="QuattrocentoSans" pitchFamily="34" charset="-122"/>
+                <a:cs typeface="QuattrocentoSans" pitchFamily="34" charset="-120"/>
+              </a:rPr>
+              <a:t>burned into every </a:t>
+            </a:r>
+            <a:r>
+              <a:rPr lang="en-US" sz="1800" b="1" dirty="0">
+                <a:solidFill>
+                  <a:srgbClr val="2D3142"/>
+                </a:solidFill>
+                <a:latin typeface="QuattrocentoSans" pitchFamily="34" charset="0"/>
+                <a:ea typeface="QuattrocentoSans" pitchFamily="34" charset="-122"/>
+                <a:cs typeface="QuattrocentoSans" pitchFamily="34" charset="-120"/>
+              </a:rPr>
+              <a:t>Network Interface Card (NIC). </a:t>
+            </a:r>
+            <a:r>
+              <a:rPr lang="en-US" sz="1800" dirty="0">
+                <a:solidFill>
+                  <a:srgbClr val="2D3142"/>
+                </a:solidFill>
+                <a:latin typeface="QuattrocentoSans" pitchFamily="34" charset="0"/>
+                <a:ea typeface="QuattrocentoSans" pitchFamily="34" charset="-122"/>
+                <a:cs typeface="QuattrocentoSans" pitchFamily="34" charset="-120"/>
+              </a:rPr>
+              <a:t>It serves as a permanent, unique identity for each network device.</a:t>
             </a:r>
             <a:endParaRPr lang="en-US" sz="1800" dirty="0"/>
           </a:p>
@@ -24401,9 +24632,20 @@
                 <a:ea typeface="QuattrocentoSans" pitchFamily="34" charset="-122"/>
                 <a:cs typeface="QuattrocentoSans" pitchFamily="34" charset="-120"/>
               </a:rPr>
-              <a:t>• First 3 pairs = manufacturer (OUI)</a:t>
-            </a:r>
-            <a:endParaRPr lang="en-US" sz="1800" dirty="0"/>
+              <a:t>• First 3 pairs = </a:t>
+            </a:r>
+            <a:r>
+              <a:rPr lang="en-US" sz="1600" b="1" dirty="0">
+                <a:solidFill>
+                  <a:srgbClr val="2D3142"/>
+                </a:solidFill>
+                <a:latin typeface="QuattrocentoSans" pitchFamily="34" charset="0"/>
+                <a:ea typeface="QuattrocentoSans" pitchFamily="34" charset="-122"/>
+                <a:cs typeface="QuattrocentoSans" pitchFamily="34" charset="-120"/>
+              </a:rPr>
+              <a:t>manufacturer (OUI)</a:t>
+            </a:r>
+            <a:endParaRPr lang="en-US" sz="1800" b="1" dirty="0"/>
           </a:p>
         </p:txBody>
       </p:sp>
@@ -24634,13 +24876,48 @@
                 <a:solidFill>
                   <a:srgbClr val="2D3142"/>
                 </a:solidFill>
+                <a:highlight>
+                  <a:srgbClr val="00FF00"/>
+                </a:highlight>
                 <a:latin typeface="QuattrocentoSans" pitchFamily="34" charset="0"/>
                 <a:ea typeface="QuattrocentoSans" pitchFamily="34" charset="-122"/>
                 <a:cs typeface="QuattrocentoSans" pitchFamily="34" charset="-120"/>
               </a:rPr>
-              <a:t>Used for local network communication only</a:t>
-            </a:r>
-            <a:endParaRPr lang="en-US" sz="1800" dirty="0"/>
+              <a:t>Used for </a:t>
+            </a:r>
+            <a:r>
+              <a:rPr lang="en-US" sz="1600" dirty="0">
+                <a:solidFill>
+                  <a:srgbClr val="2D3142"/>
+                </a:solidFill>
+                <a:highlight>
+                  <a:srgbClr val="FFFF00"/>
+                </a:highlight>
+                <a:latin typeface="QuattrocentoSans" pitchFamily="34" charset="0"/>
+                <a:ea typeface="QuattrocentoSans" pitchFamily="34" charset="-122"/>
+                <a:cs typeface="QuattrocentoSans" pitchFamily="34" charset="-120"/>
+              </a:rPr>
+              <a:t>local network communication </a:t>
+            </a:r>
+            <a:r>
+              <a:rPr lang="en-US" sz="1600" dirty="0">
+                <a:solidFill>
+                  <a:srgbClr val="2D3142"/>
+                </a:solidFill>
+                <a:highlight>
+                  <a:srgbClr val="00FF00"/>
+                </a:highlight>
+                <a:latin typeface="QuattrocentoSans" pitchFamily="34" charset="0"/>
+                <a:ea typeface="QuattrocentoSans" pitchFamily="34" charset="-122"/>
+                <a:cs typeface="QuattrocentoSans" pitchFamily="34" charset="-120"/>
+              </a:rPr>
+              <a:t>only</a:t>
+            </a:r>
+            <a:endParaRPr lang="en-US" sz="1800" dirty="0">
+              <a:highlight>
+                <a:srgbClr val="00FF00"/>
+              </a:highlight>
+            </a:endParaRPr>
           </a:p>
         </p:txBody>
       </p:sp>

</xml_diff>

<commit_message>
node js concepts added
</commit_message>
<xml_diff>
--- a/network/sir-slides/4. Networking for Web Developers.pptx
+++ b/network/sir-slides/4. Networking for Web Developers.pptx
@@ -6153,9 +6153,27 @@
                 <a:ea typeface="Quattrocento Sans" pitchFamily="34" charset="-122"/>
                 <a:cs typeface="Quattrocento Sans" pitchFamily="34" charset="-120"/>
               </a:rPr>
-              <a:t>DNS is one of the most critical systems on the Internet — every web request starts with a DNS lookup</a:t>
-            </a:r>
-            <a:endParaRPr lang="en-US" sz="1600" dirty="0"/>
+              <a:t>DNS is one of the most critical systems on the Internet — </a:t>
+            </a:r>
+            <a:r>
+              <a:rPr lang="en-US" sz="1800" b="1" dirty="0">
+                <a:solidFill>
+                  <a:srgbClr val="F4F1DE"/>
+                </a:solidFill>
+                <a:highlight>
+                  <a:srgbClr val="008000"/>
+                </a:highlight>
+                <a:latin typeface="Quattrocento Sans" pitchFamily="34" charset="0"/>
+                <a:ea typeface="Quattrocento Sans" pitchFamily="34" charset="-122"/>
+                <a:cs typeface="Quattrocento Sans" pitchFamily="34" charset="-120"/>
+              </a:rPr>
+              <a:t>every web request starts with a DNS lookup</a:t>
+            </a:r>
+            <a:endParaRPr lang="en-US" sz="1600" b="1" dirty="0">
+              <a:highlight>
+                <a:srgbClr val="008000"/>
+              </a:highlight>
+            </a:endParaRPr>
           </a:p>
         </p:txBody>
       </p:sp>
@@ -10025,7 +10043,7 @@
         </p:nvSpPr>
         <p:spPr>
           <a:xfrm>
-            <a:off x="762000" y="5651500"/>
+            <a:off x="2349500" y="5842000"/>
             <a:ext cx="14732000" cy="1016000"/>
           </a:xfrm>
           <a:prstGeom prst="rect">
@@ -10268,7 +10286,117 @@
                 <a:ea typeface="Quattrocento Sans" pitchFamily="34" charset="-122"/>
                 <a:cs typeface="Quattrocento Sans" pitchFamily="34" charset="-120"/>
               </a:rPr>
-              <a:t> the local subnet, the device sends the frame to the default gateway (router) instead, which then routes it to the external network.</a:t>
+              <a:t> the local subnet, the device sends the frame to the default gateway (router) instead, which then routes it to the external network. (website click </a:t>
+            </a:r>
+            <a:r>
+              <a:rPr lang="en-US" sz="1600" dirty="0" err="1">
+                <a:solidFill>
+                  <a:srgbClr val="F4F1DE"/>
+                </a:solidFill>
+                <a:latin typeface="Quattrocento Sans" pitchFamily="34" charset="0"/>
+                <a:ea typeface="Quattrocento Sans" pitchFamily="34" charset="-122"/>
+                <a:cs typeface="Quattrocento Sans" pitchFamily="34" charset="-120"/>
+              </a:rPr>
+              <a:t>korle</a:t>
+            </a:r>
+            <a:r>
+              <a:rPr lang="en-US" sz="1600" dirty="0">
+                <a:solidFill>
+                  <a:srgbClr val="F4F1DE"/>
+                </a:solidFill>
+                <a:latin typeface="Quattrocento Sans" pitchFamily="34" charset="0"/>
+                <a:ea typeface="Quattrocento Sans" pitchFamily="34" charset="-122"/>
+                <a:cs typeface="Quattrocento Sans" pitchFamily="34" charset="-120"/>
+              </a:rPr>
+              <a:t> gateway er </a:t>
+            </a:r>
+            <a:r>
+              <a:rPr lang="en-US" sz="1600" dirty="0" err="1">
+                <a:solidFill>
+                  <a:srgbClr val="F4F1DE"/>
+                </a:solidFill>
+                <a:latin typeface="Quattrocento Sans" pitchFamily="34" charset="0"/>
+                <a:ea typeface="Quattrocento Sans" pitchFamily="34" charset="-122"/>
+                <a:cs typeface="Quattrocento Sans" pitchFamily="34" charset="-120"/>
+              </a:rPr>
+              <a:t>kachhe</a:t>
+            </a:r>
+            <a:r>
+              <a:rPr lang="en-US" sz="1600" dirty="0">
+                <a:solidFill>
+                  <a:srgbClr val="F4F1DE"/>
+                </a:solidFill>
+                <a:latin typeface="Quattrocento Sans" pitchFamily="34" charset="0"/>
+                <a:ea typeface="Quattrocento Sans" pitchFamily="34" charset="-122"/>
+                <a:cs typeface="Quattrocento Sans" pitchFamily="34" charset="-120"/>
+              </a:rPr>
+              <a:t> jay </a:t>
+            </a:r>
+            <a:r>
+              <a:rPr lang="en-US" sz="1600" dirty="0" err="1">
+                <a:solidFill>
+                  <a:srgbClr val="F4F1DE"/>
+                </a:solidFill>
+                <a:latin typeface="Quattrocento Sans" pitchFamily="34" charset="0"/>
+                <a:ea typeface="Quattrocento Sans" pitchFamily="34" charset="-122"/>
+                <a:cs typeface="Quattrocento Sans" pitchFamily="34" charset="-120"/>
+              </a:rPr>
+              <a:t>tokhon</a:t>
+            </a:r>
+            <a:r>
+              <a:rPr lang="en-US" sz="1600" dirty="0">
+                <a:solidFill>
+                  <a:srgbClr val="F4F1DE"/>
+                </a:solidFill>
+                <a:latin typeface="Quattrocento Sans" pitchFamily="34" charset="0"/>
+                <a:ea typeface="Quattrocento Sans" pitchFamily="34" charset="-122"/>
+                <a:cs typeface="Quattrocento Sans" pitchFamily="34" charset="-120"/>
+              </a:rPr>
+              <a:t> ARP </a:t>
+            </a:r>
+            <a:r>
+              <a:rPr lang="en-US" sz="1600" dirty="0" err="1">
+                <a:solidFill>
+                  <a:srgbClr val="F4F1DE"/>
+                </a:solidFill>
+                <a:latin typeface="Quattrocento Sans" pitchFamily="34" charset="0"/>
+                <a:ea typeface="Quattrocento Sans" pitchFamily="34" charset="-122"/>
+                <a:cs typeface="Quattrocento Sans" pitchFamily="34" charset="-120"/>
+              </a:rPr>
+              <a:t>na</a:t>
+            </a:r>
+            <a:r>
+              <a:rPr lang="en-US" sz="1600" dirty="0">
+                <a:solidFill>
+                  <a:srgbClr val="F4F1DE"/>
+                </a:solidFill>
+                <a:latin typeface="Quattrocento Sans" pitchFamily="34" charset="0"/>
+                <a:ea typeface="Quattrocento Sans" pitchFamily="34" charset="-122"/>
+                <a:cs typeface="Quattrocento Sans" pitchFamily="34" charset="-120"/>
+              </a:rPr>
+              <a:t> NAT er </a:t>
+            </a:r>
+            <a:r>
+              <a:rPr lang="en-US" sz="1600" dirty="0" err="1">
+                <a:solidFill>
+                  <a:srgbClr val="F4F1DE"/>
+                </a:solidFill>
+                <a:latin typeface="Quattrocento Sans" pitchFamily="34" charset="0"/>
+                <a:ea typeface="Quattrocento Sans" pitchFamily="34" charset="-122"/>
+                <a:cs typeface="Quattrocento Sans" pitchFamily="34" charset="-120"/>
+              </a:rPr>
+              <a:t>kachhe</a:t>
+            </a:r>
+            <a:r>
+              <a:rPr lang="en-US" sz="1600">
+                <a:solidFill>
+                  <a:srgbClr val="F4F1DE"/>
+                </a:solidFill>
+                <a:latin typeface="Quattrocento Sans" pitchFamily="34" charset="0"/>
+                <a:ea typeface="Quattrocento Sans" pitchFamily="34" charset="-122"/>
+                <a:cs typeface="Quattrocento Sans" pitchFamily="34" charset="-120"/>
+              </a:rPr>
+              <a:t> jay) </a:t>
             </a:r>
             <a:endParaRPr lang="en-US" sz="1600" dirty="0"/>
           </a:p>

</xml_diff>